<commit_message>
feat(decks): generate both strategic and architecture pitch decks in PPTX format with consistent UI/UX design
</commit_message>
<xml_diff>
--- a/docs/Forecasting_Agent_Pitch_Deck.pptx
+++ b/docs/Forecasting_Agent_Pitch_Deck.pptx
@@ -3194,7 +3194,7 @@
         <p:spPr>
           <a:xfrm>
             <a:off x="731520" y="1005840"/>
-            <a:ext cx="3474720" cy="329184"/>
+            <a:ext cx="3657600" cy="329184"/>
           </a:xfrm>
           <a:prstGeom prst="roundRect">
             <a:avLst/>
@@ -3257,7 +3257,7 @@
           <a:noFill/>
         </p:spPr>
         <p:txBody>
-          <a:bodyPr wrap="square" lIns="0" rIns="0" tIns="0" bIns="0">
+          <a:bodyPr wrap="square">
             <a:spAutoFit/>
           </a:bodyPr>
           <a:lstStyle/>
@@ -3845,7 +3845,7 @@
         <p:spPr>
           <a:xfrm>
             <a:off x="731520" y="6455664"/>
-            <a:ext cx="5486400" cy="274320"/>
+            <a:ext cx="6400800" cy="274320"/>
           </a:xfrm>
           <a:prstGeom prst="rect">
             <a:avLst/>
@@ -3867,7 +3867,7 @@
               </a:defRPr>
             </a:pPr>
             <a:r>
-              <a:t>Forecasting Agent • Autonomous Multi-Agent Architecture • MVP 1</a:t>
+              <a:t>Forecasting Agent • Strategic Pitch Deck • MVP 1 Specifications</a:t>
             </a:r>
           </a:p>
         </p:txBody>
@@ -4021,7 +4021,7 @@
         <p:spPr>
           <a:xfrm>
             <a:off x="731520" y="384048"/>
-            <a:ext cx="2926080" cy="292608"/>
+            <a:ext cx="3108960" cy="292608"/>
           </a:xfrm>
           <a:prstGeom prst="roundRect">
             <a:avLst/>
@@ -4644,7 +4644,7 @@
         <p:spPr>
           <a:xfrm>
             <a:off x="731520" y="6455664"/>
-            <a:ext cx="5486400" cy="274320"/>
+            <a:ext cx="6400800" cy="274320"/>
           </a:xfrm>
           <a:prstGeom prst="rect">
             <a:avLst/>
@@ -4666,7 +4666,7 @@
               </a:defRPr>
             </a:pPr>
             <a:r>
-              <a:t>Forecasting Agent • Autonomous Multi-Agent Architecture • MVP 1</a:t>
+              <a:t>Forecasting Agent • Strategic Pitch Deck • MVP 1 Specifications</a:t>
             </a:r>
           </a:p>
         </p:txBody>
@@ -4820,7 +4820,7 @@
         <p:spPr>
           <a:xfrm>
             <a:off x="731520" y="384048"/>
-            <a:ext cx="2926080" cy="292608"/>
+            <a:ext cx="3108960" cy="292608"/>
           </a:xfrm>
           <a:prstGeom prst="roundRect">
             <a:avLst/>
@@ -5742,7 +5742,7 @@
         <p:spPr>
           <a:xfrm>
             <a:off x="731520" y="6455664"/>
-            <a:ext cx="5486400" cy="274320"/>
+            <a:ext cx="6400800" cy="274320"/>
           </a:xfrm>
           <a:prstGeom prst="rect">
             <a:avLst/>
@@ -5764,7 +5764,7 @@
               </a:defRPr>
             </a:pPr>
             <a:r>
-              <a:t>Forecasting Agent • Autonomous Multi-Agent Architecture • MVP 1</a:t>
+              <a:t>Forecasting Agent • Strategic Pitch Deck • MVP 1 Specifications</a:t>
             </a:r>
           </a:p>
         </p:txBody>
@@ -5918,7 +5918,7 @@
         <p:spPr>
           <a:xfrm>
             <a:off x="731520" y="384048"/>
-            <a:ext cx="2926080" cy="292608"/>
+            <a:ext cx="3108960" cy="292608"/>
           </a:xfrm>
           <a:prstGeom prst="roundRect">
             <a:avLst/>
@@ -6729,7 +6729,7 @@
         <p:spPr>
           <a:xfrm>
             <a:off x="731520" y="6455664"/>
-            <a:ext cx="5486400" cy="274320"/>
+            <a:ext cx="6400800" cy="274320"/>
           </a:xfrm>
           <a:prstGeom prst="rect">
             <a:avLst/>
@@ -6751,7 +6751,7 @@
               </a:defRPr>
             </a:pPr>
             <a:r>
-              <a:t>Forecasting Agent • Autonomous Multi-Agent Architecture • MVP 1</a:t>
+              <a:t>Forecasting Agent • Strategic Pitch Deck • MVP 1 Specifications</a:t>
             </a:r>
           </a:p>
         </p:txBody>
@@ -6905,7 +6905,7 @@
         <p:spPr>
           <a:xfrm>
             <a:off x="731520" y="384048"/>
-            <a:ext cx="2926080" cy="292608"/>
+            <a:ext cx="3108960" cy="292608"/>
           </a:xfrm>
           <a:prstGeom prst="roundRect">
             <a:avLst/>
@@ -7687,7 +7687,7 @@
         <p:spPr>
           <a:xfrm>
             <a:off x="731520" y="6455664"/>
-            <a:ext cx="5486400" cy="274320"/>
+            <a:ext cx="6400800" cy="274320"/>
           </a:xfrm>
           <a:prstGeom prst="rect">
             <a:avLst/>
@@ -7709,7 +7709,7 @@
               </a:defRPr>
             </a:pPr>
             <a:r>
-              <a:t>Forecasting Agent • Autonomous Multi-Agent Architecture • MVP 1</a:t>
+              <a:t>Forecasting Agent • Strategic Pitch Deck • MVP 1 Specifications</a:t>
             </a:r>
           </a:p>
         </p:txBody>
@@ -7863,7 +7863,7 @@
         <p:spPr>
           <a:xfrm>
             <a:off x="731520" y="384048"/>
-            <a:ext cx="2926080" cy="292608"/>
+            <a:ext cx="3108960" cy="292608"/>
           </a:xfrm>
           <a:prstGeom prst="roundRect">
             <a:avLst/>
@@ -8781,7 +8781,7 @@
         <p:spPr>
           <a:xfrm>
             <a:off x="731520" y="6455664"/>
-            <a:ext cx="5486400" cy="274320"/>
+            <a:ext cx="6400800" cy="274320"/>
           </a:xfrm>
           <a:prstGeom prst="rect">
             <a:avLst/>
@@ -8803,7 +8803,7 @@
               </a:defRPr>
             </a:pPr>
             <a:r>
-              <a:t>Forecasting Agent • Autonomous Multi-Agent Architecture • MVP 1</a:t>
+              <a:t>Forecasting Agent • Strategic Pitch Deck • MVP 1 Specifications</a:t>
             </a:r>
           </a:p>
         </p:txBody>
@@ -8957,7 +8957,7 @@
         <p:spPr>
           <a:xfrm>
             <a:off x="731520" y="384048"/>
-            <a:ext cx="2926080" cy="292608"/>
+            <a:ext cx="3108960" cy="292608"/>
           </a:xfrm>
           <a:prstGeom prst="roundRect">
             <a:avLst/>
@@ -9912,7 +9912,7 @@
         <p:spPr>
           <a:xfrm>
             <a:off x="731520" y="6455664"/>
-            <a:ext cx="5486400" cy="274320"/>
+            <a:ext cx="6400800" cy="274320"/>
           </a:xfrm>
           <a:prstGeom prst="rect">
             <a:avLst/>
@@ -9934,7 +9934,7 @@
               </a:defRPr>
             </a:pPr>
             <a:r>
-              <a:t>Forecasting Agent • Autonomous Multi-Agent Architecture • MVP 1</a:t>
+              <a:t>Forecasting Agent • Strategic Pitch Deck • MVP 1 Specifications</a:t>
             </a:r>
           </a:p>
         </p:txBody>
@@ -10088,7 +10088,7 @@
         <p:spPr>
           <a:xfrm>
             <a:off x="731520" y="384048"/>
-            <a:ext cx="2926080" cy="292608"/>
+            <a:ext cx="3108960" cy="292608"/>
           </a:xfrm>
           <a:prstGeom prst="roundRect">
             <a:avLst/>
@@ -10666,7 +10666,7 @@
         <p:spPr>
           <a:xfrm>
             <a:off x="731520" y="6455664"/>
-            <a:ext cx="5486400" cy="274320"/>
+            <a:ext cx="6400800" cy="274320"/>
           </a:xfrm>
           <a:prstGeom prst="rect">
             <a:avLst/>
@@ -10688,7 +10688,7 @@
               </a:defRPr>
             </a:pPr>
             <a:r>
-              <a:t>Forecasting Agent • Autonomous Multi-Agent Architecture • MVP 1</a:t>
+              <a:t>Forecasting Agent • Strategic Pitch Deck • MVP 1 Specifications</a:t>
             </a:r>
           </a:p>
         </p:txBody>
@@ -10842,7 +10842,7 @@
         <p:spPr>
           <a:xfrm>
             <a:off x="731520" y="384048"/>
-            <a:ext cx="2926080" cy="292608"/>
+            <a:ext cx="3108960" cy="292608"/>
           </a:xfrm>
           <a:prstGeom prst="roundRect">
             <a:avLst/>
@@ -11792,7 +11792,7 @@
         <p:spPr>
           <a:xfrm>
             <a:off x="731520" y="6455664"/>
-            <a:ext cx="5486400" cy="274320"/>
+            <a:ext cx="6400800" cy="274320"/>
           </a:xfrm>
           <a:prstGeom prst="rect">
             <a:avLst/>
@@ -11814,7 +11814,7 @@
               </a:defRPr>
             </a:pPr>
             <a:r>
-              <a:t>Forecasting Agent • Autonomous Multi-Agent Architecture • MVP 1</a:t>
+              <a:t>Forecasting Agent • Strategic Pitch Deck • MVP 1 Specifications</a:t>
             </a:r>
           </a:p>
         </p:txBody>
@@ -11968,7 +11968,7 @@
         <p:spPr>
           <a:xfrm>
             <a:off x="731520" y="384048"/>
-            <a:ext cx="2926080" cy="292608"/>
+            <a:ext cx="3108960" cy="292608"/>
           </a:xfrm>
           <a:prstGeom prst="roundRect">
             <a:avLst/>
@@ -12750,7 +12750,7 @@
         <p:spPr>
           <a:xfrm>
             <a:off x="731520" y="6455664"/>
-            <a:ext cx="5486400" cy="274320"/>
+            <a:ext cx="6400800" cy="274320"/>
           </a:xfrm>
           <a:prstGeom prst="rect">
             <a:avLst/>
@@ -12772,7 +12772,7 @@
               </a:defRPr>
             </a:pPr>
             <a:r>
-              <a:t>Forecasting Agent • Autonomous Multi-Agent Architecture • MVP 1</a:t>
+              <a:t>Forecasting Agent • Strategic Pitch Deck • MVP 1 Specifications</a:t>
             </a:r>
           </a:p>
         </p:txBody>
@@ -12926,7 +12926,7 @@
         <p:spPr>
           <a:xfrm>
             <a:off x="731520" y="384048"/>
-            <a:ext cx="2926080" cy="292608"/>
+            <a:ext cx="3108960" cy="292608"/>
           </a:xfrm>
           <a:prstGeom prst="roundRect">
             <a:avLst/>
@@ -13800,7 +13800,7 @@
         <p:spPr>
           <a:xfrm>
             <a:off x="731520" y="6455664"/>
-            <a:ext cx="5486400" cy="274320"/>
+            <a:ext cx="6400800" cy="274320"/>
           </a:xfrm>
           <a:prstGeom prst="rect">
             <a:avLst/>
@@ -13822,7 +13822,7 @@
               </a:defRPr>
             </a:pPr>
             <a:r>
-              <a:t>Forecasting Agent • Autonomous Multi-Agent Architecture • MVP 1</a:t>
+              <a:t>Forecasting Agent • Strategic Pitch Deck • MVP 1 Specifications</a:t>
             </a:r>
           </a:p>
         </p:txBody>
@@ -13976,7 +13976,7 @@
         <p:spPr>
           <a:xfrm>
             <a:off x="731520" y="384048"/>
-            <a:ext cx="2926080" cy="292608"/>
+            <a:ext cx="3108960" cy="292608"/>
           </a:xfrm>
           <a:prstGeom prst="roundRect">
             <a:avLst/>
@@ -15041,7 +15041,7 @@
         <p:spPr>
           <a:xfrm>
             <a:off x="731520" y="6455664"/>
-            <a:ext cx="5486400" cy="274320"/>
+            <a:ext cx="6400800" cy="274320"/>
           </a:xfrm>
           <a:prstGeom prst="rect">
             <a:avLst/>
@@ -15063,7 +15063,7 @@
               </a:defRPr>
             </a:pPr>
             <a:r>
-              <a:t>Forecasting Agent • Autonomous Multi-Agent Architecture • MVP 1</a:t>
+              <a:t>Forecasting Agent • Strategic Pitch Deck • MVP 1 Specifications</a:t>
             </a:r>
           </a:p>
         </p:txBody>

</xml_diff>